<commit_message>
replace poster template file
</commit_message>
<xml_diff>
--- a/project/report/examples/E80_PosterTemplate.pptx
+++ b/project/report/examples/E80_PosterTemplate.pptx
@@ -281,7 +281,7 @@
       </p15:sldGuideLst>
     </p:ext>
     <p:ext uri="GoogleSlidesCustomDataVersion2">
-      <go:slidesCustomData xmlns="" xmlns:mc="http://schemas.openxmlformats.org/markup-compatibility/2006" xmlns:mv="urn:schemas-microsoft-com:mac:vml" xmlns:c="http://schemas.openxmlformats.org/drawingml/2006/chart" xmlns:dgm="http://schemas.openxmlformats.org/drawingml/2006/diagram" xmlns:o="urn:schemas-microsoft-com:office:office" xmlns:v="urn:schemas-microsoft-com:vml" xmlns:pvml="urn:schemas-microsoft-com:office:powerpoint" xmlns:com="http://schemas.openxmlformats.org/drawingml/2006/compatibility" xmlns:p14="http://schemas.microsoft.com/office/powerpoint/2010/main" xmlns:p15="http://schemas.microsoft.com/office/powerpoint/2012/main" xmlns:ahyp="http://schemas.microsoft.com/office/drawing/2018/hyperlinkcolor" xmlns:go="http://customooxmlschemas.google.com/" r:id="rId15" roundtripDataSignature="AMtx7mgABUS0pw/xbTfJumNVOI3o+tmuyQ=="/>
+      <go:slidesCustomData xmlns:go="http://customooxmlschemas.google.com/" xmlns:ahyp="http://schemas.microsoft.com/office/drawing/2018/hyperlinkcolor" xmlns:p15="http://schemas.microsoft.com/office/powerpoint/2012/main" xmlns:p14="http://schemas.microsoft.com/office/powerpoint/2010/main" xmlns:com="http://schemas.openxmlformats.org/drawingml/2006/compatibility" xmlns:pvml="urn:schemas-microsoft-com:office:powerpoint" xmlns:v="urn:schemas-microsoft-com:vml" xmlns:o="urn:schemas-microsoft-com:office:office" xmlns:dgm="http://schemas.openxmlformats.org/drawingml/2006/diagram" xmlns:c="http://schemas.openxmlformats.org/drawingml/2006/chart" xmlns:mv="urn:schemas-microsoft-com:mac:vml" xmlns:mc="http://schemas.openxmlformats.org/markup-compatibility/2006" xmlns="" r:id="rId15" roundtripDataSignature="AMtx7mgABUS0pw/xbTfJumNVOI3o+tmuyQ=="/>
     </p:ext>
   </p:extLst>
 </p:presentation>
@@ -14669,7 +14669,7 @@
                 <a:cs typeface="Helvetica Neue"/>
                 <a:sym typeface="Helvetica Neue"/>
               </a:rPr>
-              <a:t>Location(s): &lt;</a:t>
+              <a:t>Location(s): </a:t>
             </a:r>
             <a:r>
               <a:rPr lang="en-US" sz="3600" dirty="0">
@@ -14681,7 +14681,7 @@
                 <a:cs typeface="Helvetica Neue"/>
                 <a:sym typeface="Helvetica Neue"/>
               </a:rPr>
-              <a:t>where you tested&gt;</a:t>
+              <a:t>&lt;where you tested&gt;</a:t>
             </a:r>
             <a:endParaRPr sz="3600" dirty="0">
               <a:solidFill>
@@ -14721,7 +14721,7 @@
                 <a:cs typeface="Helvetica Neue"/>
                 <a:sym typeface="Helvetica Neue"/>
               </a:rPr>
-              <a:t>Testing Protocol: &lt;</a:t>
+              <a:t>Testing Protocol: </a:t>
             </a:r>
             <a:r>
               <a:rPr lang="en-US" sz="3600" dirty="0">
@@ -14733,7 +14733,50 @@
                 <a:cs typeface="Helvetica Neue"/>
                 <a:sym typeface="Helvetica Neue"/>
               </a:rPr>
-              <a:t>how you prepared for deployment and tested your robot&gt;</a:t>
+              <a:t>&lt;how you prepared for deployment and tested your robot&gt;</a:t>
+            </a:r>
+          </a:p>
+          <a:p>
+            <a:pPr marL="457200" marR="0" lvl="0" indent="0" algn="l" rtl="0">
+              <a:lnSpc>
+                <a:spcPct val="115000"/>
+              </a:lnSpc>
+              <a:spcBef>
+                <a:spcPts val="1000"/>
+              </a:spcBef>
+              <a:spcAft>
+                <a:spcPts val="0"/>
+              </a:spcAft>
+              <a:buClr>
+                <a:srgbClr val="000000"/>
+              </a:buClr>
+              <a:buSzPts val="3500"/>
+              <a:buFont typeface="Arial"/>
+              <a:buNone/>
+            </a:pPr>
+            <a:r>
+              <a:rPr lang="en-US" sz="3600" b="1" i="0" u="none" strike="noStrike" cap="none" dirty="0">
+                <a:solidFill>
+                  <a:schemeClr val="dk1"/>
+                </a:solidFill>
+                <a:latin typeface="Helvetica Neue"/>
+                <a:ea typeface="Helvetica Neue"/>
+                <a:cs typeface="Helvetica Neue"/>
+                <a:sym typeface="Helvetica Neue"/>
+              </a:rPr>
+              <a:t>Safety: </a:t>
+            </a:r>
+            <a:r>
+              <a:rPr lang="en-US" sz="3600" dirty="0">
+                <a:solidFill>
+                  <a:schemeClr val="dk1"/>
+                </a:solidFill>
+                <a:latin typeface="Helvetica Neue"/>
+                <a:ea typeface="Helvetica Neue"/>
+                <a:cs typeface="Helvetica Neue"/>
+                <a:sym typeface="Helvetica Neue"/>
+              </a:rPr>
+              <a:t>&lt;what safety measures were taken?&gt;</a:t>
             </a:r>
             <a:endParaRPr sz="3600" i="0" u="none" strike="noStrike" cap="none" dirty="0">
               <a:solidFill>

</xml_diff>